<commit_message>
Most things ready for tamu nov 25
</commit_message>
<xml_diff>
--- a/Test Plans/Test Plan Diagrams.pptx
+++ b/Test Plans/Test Plan Diagrams.pptx
@@ -7,6 +7,7 @@
   <p:sldIdLst>
     <p:sldId id="256" r:id="rId2"/>
     <p:sldId id="257" r:id="rId3"/>
+    <p:sldId id="258" r:id="rId4"/>
   </p:sldIdLst>
   <p:sldSz cx="12192000" cy="6858000"/>
   <p:notesSz cx="6858000" cy="9144000"/>
@@ -260,7 +261,7 @@
           <a:p>
             <a:fld id="{34AE675B-3063-4D30-AFE0-95960C6CE18E}" type="datetimeFigureOut">
               <a:rPr lang="en-US" smtClean="0"/>
-              <a:t>5/13/2025</a:t>
+              <a:t>10/24/2025</a:t>
             </a:fld>
             <a:endParaRPr lang="en-US"/>
           </a:p>
@@ -458,7 +459,7 @@
           <a:p>
             <a:fld id="{34AE675B-3063-4D30-AFE0-95960C6CE18E}" type="datetimeFigureOut">
               <a:rPr lang="en-US" smtClean="0"/>
-              <a:t>5/13/2025</a:t>
+              <a:t>10/24/2025</a:t>
             </a:fld>
             <a:endParaRPr lang="en-US"/>
           </a:p>
@@ -666,7 +667,7 @@
           <a:p>
             <a:fld id="{34AE675B-3063-4D30-AFE0-95960C6CE18E}" type="datetimeFigureOut">
               <a:rPr lang="en-US" smtClean="0"/>
-              <a:t>5/13/2025</a:t>
+              <a:t>10/24/2025</a:t>
             </a:fld>
             <a:endParaRPr lang="en-US"/>
           </a:p>
@@ -864,7 +865,7 @@
           <a:p>
             <a:fld id="{34AE675B-3063-4D30-AFE0-95960C6CE18E}" type="datetimeFigureOut">
               <a:rPr lang="en-US" smtClean="0"/>
-              <a:t>5/13/2025</a:t>
+              <a:t>10/24/2025</a:t>
             </a:fld>
             <a:endParaRPr lang="en-US"/>
           </a:p>
@@ -1139,7 +1140,7 @@
           <a:p>
             <a:fld id="{34AE675B-3063-4D30-AFE0-95960C6CE18E}" type="datetimeFigureOut">
               <a:rPr lang="en-US" smtClean="0"/>
-              <a:t>5/13/2025</a:t>
+              <a:t>10/24/2025</a:t>
             </a:fld>
             <a:endParaRPr lang="en-US"/>
           </a:p>
@@ -1404,7 +1405,7 @@
           <a:p>
             <a:fld id="{34AE675B-3063-4D30-AFE0-95960C6CE18E}" type="datetimeFigureOut">
               <a:rPr lang="en-US" smtClean="0"/>
-              <a:t>5/13/2025</a:t>
+              <a:t>10/24/2025</a:t>
             </a:fld>
             <a:endParaRPr lang="en-US"/>
           </a:p>
@@ -1816,7 +1817,7 @@
           <a:p>
             <a:fld id="{34AE675B-3063-4D30-AFE0-95960C6CE18E}" type="datetimeFigureOut">
               <a:rPr lang="en-US" smtClean="0"/>
-              <a:t>5/13/2025</a:t>
+              <a:t>10/24/2025</a:t>
             </a:fld>
             <a:endParaRPr lang="en-US"/>
           </a:p>
@@ -1957,7 +1958,7 @@
           <a:p>
             <a:fld id="{34AE675B-3063-4D30-AFE0-95960C6CE18E}" type="datetimeFigureOut">
               <a:rPr lang="en-US" smtClean="0"/>
-              <a:t>5/13/2025</a:t>
+              <a:t>10/24/2025</a:t>
             </a:fld>
             <a:endParaRPr lang="en-US"/>
           </a:p>
@@ -2070,7 +2071,7 @@
           <a:p>
             <a:fld id="{34AE675B-3063-4D30-AFE0-95960C6CE18E}" type="datetimeFigureOut">
               <a:rPr lang="en-US" smtClean="0"/>
-              <a:t>5/13/2025</a:t>
+              <a:t>10/24/2025</a:t>
             </a:fld>
             <a:endParaRPr lang="en-US"/>
           </a:p>
@@ -2381,7 +2382,7 @@
           <a:p>
             <a:fld id="{34AE675B-3063-4D30-AFE0-95960C6CE18E}" type="datetimeFigureOut">
               <a:rPr lang="en-US" smtClean="0"/>
-              <a:t>5/13/2025</a:t>
+              <a:t>10/24/2025</a:t>
             </a:fld>
             <a:endParaRPr lang="en-US"/>
           </a:p>
@@ -2669,7 +2670,7 @@
           <a:p>
             <a:fld id="{34AE675B-3063-4D30-AFE0-95960C6CE18E}" type="datetimeFigureOut">
               <a:rPr lang="en-US" smtClean="0"/>
-              <a:t>5/13/2025</a:t>
+              <a:t>10/24/2025</a:t>
             </a:fld>
             <a:endParaRPr lang="en-US"/>
           </a:p>
@@ -2910,7 +2911,7 @@
           <a:p>
             <a:fld id="{34AE675B-3063-4D30-AFE0-95960C6CE18E}" type="datetimeFigureOut">
               <a:rPr lang="en-US" smtClean="0"/>
-              <a:t>5/13/2025</a:t>
+              <a:t>10/24/2025</a:t>
             </a:fld>
             <a:endParaRPr lang="en-US"/>
           </a:p>
@@ -3531,7 +3532,7 @@
               <a:lstStyle/>
               <a:p>
                 <a:pPr algn="ctr"/>
-                <a:endParaRPr lang="en-US"/>
+                <a:endParaRPr lang="en-US" dirty="0"/>
               </a:p>
             </p:txBody>
           </p:sp>
@@ -5289,6 +5290,1387 @@
 </p:sld>
 </file>
 
+<file path=ppt/slides/slide3.xml><?xml version="1.0" encoding="utf-8"?>
+<p:sld xmlns:a="http://schemas.openxmlformats.org/drawingml/2006/main" xmlns:r="http://schemas.openxmlformats.org/officeDocument/2006/relationships" xmlns:p="http://schemas.openxmlformats.org/presentationml/2006/main">
+  <p:cSld>
+    <p:spTree>
+      <p:nvGrpSpPr>
+        <p:cNvPr id="1" name=""/>
+        <p:cNvGrpSpPr/>
+        <p:nvPr/>
+      </p:nvGrpSpPr>
+      <p:grpSpPr>
+        <a:xfrm>
+          <a:off x="0" y="0"/>
+          <a:ext cx="0" cy="0"/>
+          <a:chOff x="0" y="0"/>
+          <a:chExt cx="0" cy="0"/>
+        </a:xfrm>
+      </p:grpSpPr>
+      <p:pic>
+        <p:nvPicPr>
+          <p:cNvPr id="1026" name="Picture 2" descr="schematic 4">
+            <a:extLst>
+              <a:ext uri="{FF2B5EF4-FFF2-40B4-BE49-F238E27FC236}">
+                <a16:creationId xmlns:a16="http://schemas.microsoft.com/office/drawing/2014/main" id="{B5679B99-94F3-5012-1CE7-F64C15C855D1}"/>
+              </a:ext>
+            </a:extLst>
+          </p:cNvPr>
+          <p:cNvPicPr>
+            <a:picLocks noChangeAspect="1" noChangeArrowheads="1"/>
+          </p:cNvPicPr>
+          <p:nvPr/>
+        </p:nvPicPr>
+        <p:blipFill>
+          <a:blip r:embed="rId2">
+            <a:extLst>
+              <a:ext uri="{28A0092B-C50C-407E-A947-70E740481C1C}">
+                <a14:useLocalDpi xmlns:a14="http://schemas.microsoft.com/office/drawing/2010/main" val="0"/>
+              </a:ext>
+            </a:extLst>
+          </a:blip>
+          <a:srcRect/>
+          <a:stretch>
+            <a:fillRect/>
+          </a:stretch>
+        </p:blipFill>
+        <p:spPr bwMode="auto">
+          <a:xfrm rot="10800000">
+            <a:off x="4066073" y="1857674"/>
+            <a:ext cx="4059854" cy="3826041"/>
+          </a:xfrm>
+          <a:prstGeom prst="rect">
+            <a:avLst/>
+          </a:prstGeom>
+          <a:noFill/>
+          <a:extLst>
+            <a:ext uri="{909E8E84-426E-40DD-AFC4-6F175D3DCCD1}">
+              <a14:hiddenFill xmlns:a14="http://schemas.microsoft.com/office/drawing/2010/main">
+                <a:solidFill>
+                  <a:srgbClr val="FFFFFF"/>
+                </a:solidFill>
+              </a14:hiddenFill>
+            </a:ext>
+          </a:extLst>
+        </p:spPr>
+      </p:pic>
+      <p:pic>
+        <p:nvPicPr>
+          <p:cNvPr id="2" name="Picture 2" descr="Synthesized Signal Generator: HMC-T2270 | Microwave Journal">
+            <a:extLst>
+              <a:ext uri="{FF2B5EF4-FFF2-40B4-BE49-F238E27FC236}">
+                <a16:creationId xmlns:a16="http://schemas.microsoft.com/office/drawing/2014/main" id="{41DDE1DC-0025-130D-A104-D718854601B9}"/>
+              </a:ext>
+            </a:extLst>
+          </p:cNvPr>
+          <p:cNvPicPr>
+            <a:picLocks noChangeAspect="1" noChangeArrowheads="1"/>
+          </p:cNvPicPr>
+          <p:nvPr/>
+        </p:nvPicPr>
+        <p:blipFill>
+          <a:blip r:embed="rId3">
+            <a:extLst>
+              <a:ext uri="{28A0092B-C50C-407E-A947-70E740481C1C}">
+                <a14:useLocalDpi xmlns:a14="http://schemas.microsoft.com/office/drawing/2010/main" val="0"/>
+              </a:ext>
+            </a:extLst>
+          </a:blip>
+          <a:srcRect/>
+          <a:stretch>
+            <a:fillRect/>
+          </a:stretch>
+        </p:blipFill>
+        <p:spPr bwMode="auto">
+          <a:xfrm>
+            <a:off x="9841100" y="1669648"/>
+            <a:ext cx="1385545" cy="879821"/>
+          </a:xfrm>
+          <a:prstGeom prst="rect">
+            <a:avLst/>
+          </a:prstGeom>
+          <a:noFill/>
+          <a:extLst>
+            <a:ext uri="{909E8E84-426E-40DD-AFC4-6F175D3DCCD1}">
+              <a14:hiddenFill xmlns:a14="http://schemas.microsoft.com/office/drawing/2010/main">
+                <a:solidFill>
+                  <a:srgbClr val="FFFFFF"/>
+                </a:solidFill>
+              </a14:hiddenFill>
+            </a:ext>
+          </a:extLst>
+        </p:spPr>
+      </p:pic>
+      <p:sp>
+        <p:nvSpPr>
+          <p:cNvPr id="3" name="TextBox 2">
+            <a:extLst>
+              <a:ext uri="{FF2B5EF4-FFF2-40B4-BE49-F238E27FC236}">
+                <a16:creationId xmlns:a16="http://schemas.microsoft.com/office/drawing/2014/main" id="{0D725BEE-8D61-5675-9DD4-A2D7DD4117D0}"/>
+              </a:ext>
+            </a:extLst>
+          </p:cNvPr>
+          <p:cNvSpPr txBox="1"/>
+          <p:nvPr/>
+        </p:nvSpPr>
+        <p:spPr>
+          <a:xfrm>
+            <a:off x="9692640" y="1244863"/>
+            <a:ext cx="1732547" cy="369332"/>
+          </a:xfrm>
+          <a:prstGeom prst="rect">
+            <a:avLst/>
+          </a:prstGeom>
+          <a:noFill/>
+        </p:spPr>
+        <p:txBody>
+          <a:bodyPr wrap="square" rtlCol="0">
+            <a:spAutoFit/>
+          </a:bodyPr>
+          <a:lstStyle/>
+          <a:p>
+            <a:r>
+              <a:rPr lang="en-US" dirty="0"/>
+              <a:t>Hittite 0</a:t>
+            </a:r>
+          </a:p>
+        </p:txBody>
+      </p:sp>
+      <p:pic>
+        <p:nvPicPr>
+          <p:cNvPr id="4" name="Picture 2" descr="Synthesized Signal Generator: HMC-T2270 | Microwave Journal">
+            <a:extLst>
+              <a:ext uri="{FF2B5EF4-FFF2-40B4-BE49-F238E27FC236}">
+                <a16:creationId xmlns:a16="http://schemas.microsoft.com/office/drawing/2014/main" id="{645622E7-BB12-813F-B9A3-D1BF120EFD4E}"/>
+              </a:ext>
+            </a:extLst>
+          </p:cNvPr>
+          <p:cNvPicPr>
+            <a:picLocks noChangeAspect="1" noChangeArrowheads="1"/>
+          </p:cNvPicPr>
+          <p:nvPr/>
+        </p:nvPicPr>
+        <p:blipFill>
+          <a:blip r:embed="rId3">
+            <a:extLst>
+              <a:ext uri="{28A0092B-C50C-407E-A947-70E740481C1C}">
+                <a14:useLocalDpi xmlns:a14="http://schemas.microsoft.com/office/drawing/2010/main" val="0"/>
+              </a:ext>
+            </a:extLst>
+          </a:blip>
+          <a:srcRect/>
+          <a:stretch>
+            <a:fillRect/>
+          </a:stretch>
+        </p:blipFill>
+        <p:spPr bwMode="auto">
+          <a:xfrm>
+            <a:off x="2736421" y="459055"/>
+            <a:ext cx="1385545" cy="879821"/>
+          </a:xfrm>
+          <a:prstGeom prst="rect">
+            <a:avLst/>
+          </a:prstGeom>
+          <a:noFill/>
+          <a:extLst>
+            <a:ext uri="{909E8E84-426E-40DD-AFC4-6F175D3DCCD1}">
+              <a14:hiddenFill xmlns:a14="http://schemas.microsoft.com/office/drawing/2010/main">
+                <a:solidFill>
+                  <a:srgbClr val="FFFFFF"/>
+                </a:solidFill>
+              </a14:hiddenFill>
+            </a:ext>
+          </a:extLst>
+        </p:spPr>
+      </p:pic>
+      <p:sp>
+        <p:nvSpPr>
+          <p:cNvPr id="5" name="TextBox 4">
+            <a:extLst>
+              <a:ext uri="{FF2B5EF4-FFF2-40B4-BE49-F238E27FC236}">
+                <a16:creationId xmlns:a16="http://schemas.microsoft.com/office/drawing/2014/main" id="{3133FD31-07CA-3464-C1AD-856D16DDA4F3}"/>
+              </a:ext>
+            </a:extLst>
+          </p:cNvPr>
+          <p:cNvSpPr txBox="1"/>
+          <p:nvPr/>
+        </p:nvSpPr>
+        <p:spPr>
+          <a:xfrm>
+            <a:off x="2587961" y="34270"/>
+            <a:ext cx="1732547" cy="369332"/>
+          </a:xfrm>
+          <a:prstGeom prst="rect">
+            <a:avLst/>
+          </a:prstGeom>
+          <a:noFill/>
+        </p:spPr>
+        <p:txBody>
+          <a:bodyPr wrap="square" rtlCol="0">
+            <a:spAutoFit/>
+          </a:bodyPr>
+          <a:lstStyle/>
+          <a:p>
+            <a:r>
+              <a:rPr lang="en-US" dirty="0"/>
+              <a:t>Hittite 1</a:t>
+            </a:r>
+          </a:p>
+        </p:txBody>
+      </p:sp>
+      <p:sp>
+        <p:nvSpPr>
+          <p:cNvPr id="6" name="Rectangle: Rounded Corners 5">
+            <a:extLst>
+              <a:ext uri="{FF2B5EF4-FFF2-40B4-BE49-F238E27FC236}">
+                <a16:creationId xmlns:a16="http://schemas.microsoft.com/office/drawing/2014/main" id="{EAD4F884-AF4B-472B-C9E4-DCAC1C811B84}"/>
+              </a:ext>
+            </a:extLst>
+          </p:cNvPr>
+          <p:cNvSpPr/>
+          <p:nvPr/>
+        </p:nvSpPr>
+        <p:spPr>
+          <a:xfrm>
+            <a:off x="9217699" y="3202767"/>
+            <a:ext cx="2275150" cy="775226"/>
+          </a:xfrm>
+          <a:prstGeom prst="roundRect">
+            <a:avLst/>
+          </a:prstGeom>
+        </p:spPr>
+        <p:style>
+          <a:lnRef idx="2">
+            <a:schemeClr val="accent1">
+              <a:shade val="15000"/>
+            </a:schemeClr>
+          </a:lnRef>
+          <a:fillRef idx="1">
+            <a:schemeClr val="accent1"/>
+          </a:fillRef>
+          <a:effectRef idx="0">
+            <a:schemeClr val="accent1"/>
+          </a:effectRef>
+          <a:fontRef idx="minor">
+            <a:schemeClr val="lt1"/>
+          </a:fontRef>
+        </p:style>
+        <p:txBody>
+          <a:bodyPr rtlCol="0" anchor="ctr"/>
+          <a:lstStyle/>
+          <a:p>
+            <a:pPr algn="ctr"/>
+            <a:endParaRPr lang="en-US" dirty="0"/>
+          </a:p>
+        </p:txBody>
+      </p:sp>
+      <p:sp>
+        <p:nvSpPr>
+          <p:cNvPr id="7" name="TextBox 6">
+            <a:extLst>
+              <a:ext uri="{FF2B5EF4-FFF2-40B4-BE49-F238E27FC236}">
+                <a16:creationId xmlns:a16="http://schemas.microsoft.com/office/drawing/2014/main" id="{0ED4418D-264E-7E78-EDF7-F2CA0E0241CB}"/>
+              </a:ext>
+            </a:extLst>
+          </p:cNvPr>
+          <p:cNvSpPr txBox="1"/>
+          <p:nvPr/>
+        </p:nvSpPr>
+        <p:spPr>
+          <a:xfrm>
+            <a:off x="10002304" y="3401362"/>
+            <a:ext cx="1309035" cy="369332"/>
+          </a:xfrm>
+          <a:prstGeom prst="rect">
+            <a:avLst/>
+          </a:prstGeom>
+          <a:noFill/>
+        </p:spPr>
+        <p:txBody>
+          <a:bodyPr wrap="square" rtlCol="0">
+            <a:spAutoFit/>
+          </a:bodyPr>
+          <a:lstStyle/>
+          <a:p>
+            <a:r>
+              <a:rPr lang="en-US" dirty="0"/>
+              <a:t>BAL0010</a:t>
+            </a:r>
+          </a:p>
+        </p:txBody>
+      </p:sp>
+      <p:sp>
+        <p:nvSpPr>
+          <p:cNvPr id="8" name="TextBox 7">
+            <a:extLst>
+              <a:ext uri="{FF2B5EF4-FFF2-40B4-BE49-F238E27FC236}">
+                <a16:creationId xmlns:a16="http://schemas.microsoft.com/office/drawing/2014/main" id="{A961CB76-4798-2390-D9CF-B79909B36266}"/>
+              </a:ext>
+            </a:extLst>
+          </p:cNvPr>
+          <p:cNvSpPr txBox="1"/>
+          <p:nvPr/>
+        </p:nvSpPr>
+        <p:spPr>
+          <a:xfrm>
+            <a:off x="11049953" y="3359440"/>
+            <a:ext cx="505089" cy="369332"/>
+          </a:xfrm>
+          <a:prstGeom prst="rect">
+            <a:avLst/>
+          </a:prstGeom>
+          <a:noFill/>
+        </p:spPr>
+        <p:txBody>
+          <a:bodyPr wrap="square" rtlCol="0">
+            <a:spAutoFit/>
+          </a:bodyPr>
+          <a:lstStyle/>
+          <a:p>
+            <a:r>
+              <a:rPr lang="en-US" dirty="0"/>
+              <a:t>IN</a:t>
+            </a:r>
+          </a:p>
+        </p:txBody>
+      </p:sp>
+      <p:cxnSp>
+        <p:nvCxnSpPr>
+          <p:cNvPr id="10" name="Connector: Elbow 9">
+            <a:extLst>
+              <a:ext uri="{FF2B5EF4-FFF2-40B4-BE49-F238E27FC236}">
+                <a16:creationId xmlns:a16="http://schemas.microsoft.com/office/drawing/2014/main" id="{134FE598-B71E-046E-5E96-A9840D788B99}"/>
+              </a:ext>
+            </a:extLst>
+          </p:cNvPr>
+          <p:cNvCxnSpPr/>
+          <p:nvPr/>
+        </p:nvCxnSpPr>
+        <p:spPr>
+          <a:xfrm rot="10800000" flipV="1">
+            <a:off x="8125928" y="3108960"/>
+            <a:ext cx="1715173" cy="202947"/>
+          </a:xfrm>
+          <a:prstGeom prst="bentConnector3">
+            <a:avLst>
+              <a:gd name="adj1" fmla="val 70817"/>
+            </a:avLst>
+          </a:prstGeom>
+          <a:ln>
+            <a:tailEnd type="triangle"/>
+          </a:ln>
+        </p:spPr>
+        <p:style>
+          <a:lnRef idx="2">
+            <a:schemeClr val="accent1"/>
+          </a:lnRef>
+          <a:fillRef idx="0">
+            <a:schemeClr val="accent1"/>
+          </a:fillRef>
+          <a:effectRef idx="1">
+            <a:schemeClr val="accent1"/>
+          </a:effectRef>
+          <a:fontRef idx="minor">
+            <a:schemeClr val="tx1"/>
+          </a:fontRef>
+        </p:style>
+      </p:cxnSp>
+      <p:cxnSp>
+        <p:nvCxnSpPr>
+          <p:cNvPr id="12" name="Connector: Elbow 11">
+            <a:extLst>
+              <a:ext uri="{FF2B5EF4-FFF2-40B4-BE49-F238E27FC236}">
+                <a16:creationId xmlns:a16="http://schemas.microsoft.com/office/drawing/2014/main" id="{756E85AB-32D7-8A18-ADB2-7028DF5F14F2}"/>
+              </a:ext>
+            </a:extLst>
+          </p:cNvPr>
+          <p:cNvCxnSpPr>
+            <a:cxnSpLocks/>
+          </p:cNvCxnSpPr>
+          <p:nvPr/>
+        </p:nvCxnSpPr>
+        <p:spPr>
+          <a:xfrm rot="10800000">
+            <a:off x="8125927" y="3832232"/>
+            <a:ext cx="1715173" cy="202947"/>
+          </a:xfrm>
+          <a:prstGeom prst="bentConnector3">
+            <a:avLst>
+              <a:gd name="adj1" fmla="val 70817"/>
+            </a:avLst>
+          </a:prstGeom>
+          <a:ln>
+            <a:tailEnd type="triangle"/>
+          </a:ln>
+        </p:spPr>
+        <p:style>
+          <a:lnRef idx="2">
+            <a:schemeClr val="accent1"/>
+          </a:lnRef>
+          <a:fillRef idx="0">
+            <a:schemeClr val="accent1"/>
+          </a:fillRef>
+          <a:effectRef idx="1">
+            <a:schemeClr val="accent1"/>
+          </a:effectRef>
+          <a:fontRef idx="minor">
+            <a:schemeClr val="tx1"/>
+          </a:fontRef>
+        </p:style>
+      </p:cxnSp>
+      <p:sp>
+        <p:nvSpPr>
+          <p:cNvPr id="13" name="Arrow: Bent 12">
+            <a:extLst>
+              <a:ext uri="{FF2B5EF4-FFF2-40B4-BE49-F238E27FC236}">
+                <a16:creationId xmlns:a16="http://schemas.microsoft.com/office/drawing/2014/main" id="{6835438E-C0DA-79EA-F663-CFC904F81302}"/>
+              </a:ext>
+            </a:extLst>
+          </p:cNvPr>
+          <p:cNvSpPr/>
+          <p:nvPr/>
+        </p:nvSpPr>
+        <p:spPr>
+          <a:xfrm rot="5400000">
+            <a:off x="10910693" y="2392001"/>
+            <a:ext cx="1029446" cy="320040"/>
+          </a:xfrm>
+          <a:prstGeom prst="bentArrow">
+            <a:avLst/>
+          </a:prstGeom>
+        </p:spPr>
+        <p:style>
+          <a:lnRef idx="2">
+            <a:schemeClr val="accent1">
+              <a:shade val="15000"/>
+            </a:schemeClr>
+          </a:lnRef>
+          <a:fillRef idx="1">
+            <a:schemeClr val="accent1"/>
+          </a:fillRef>
+          <a:effectRef idx="0">
+            <a:schemeClr val="accent1"/>
+          </a:effectRef>
+          <a:fontRef idx="minor">
+            <a:schemeClr val="lt1"/>
+          </a:fontRef>
+        </p:style>
+        <p:txBody>
+          <a:bodyPr rtlCol="0" anchor="ctr"/>
+          <a:lstStyle/>
+          <a:p>
+            <a:pPr algn="ctr"/>
+            <a:endParaRPr lang="en-US">
+              <a:solidFill>
+                <a:schemeClr val="tx1"/>
+              </a:solidFill>
+            </a:endParaRPr>
+          </a:p>
+        </p:txBody>
+      </p:sp>
+      <p:sp>
+        <p:nvSpPr>
+          <p:cNvPr id="14" name="TextBox 13">
+            <a:extLst>
+              <a:ext uri="{FF2B5EF4-FFF2-40B4-BE49-F238E27FC236}">
+                <a16:creationId xmlns:a16="http://schemas.microsoft.com/office/drawing/2014/main" id="{66ECB5F8-C104-DE52-9283-3F87EE509F88}"/>
+              </a:ext>
+            </a:extLst>
+          </p:cNvPr>
+          <p:cNvSpPr txBox="1"/>
+          <p:nvPr/>
+        </p:nvSpPr>
+        <p:spPr>
+          <a:xfrm>
+            <a:off x="9624588" y="3165648"/>
+            <a:ext cx="482188" cy="369332"/>
+          </a:xfrm>
+          <a:prstGeom prst="rect">
+            <a:avLst/>
+          </a:prstGeom>
+          <a:noFill/>
+        </p:spPr>
+        <p:txBody>
+          <a:bodyPr wrap="square" rtlCol="0">
+            <a:spAutoFit/>
+          </a:bodyPr>
+          <a:lstStyle/>
+          <a:p>
+            <a:r>
+              <a:rPr lang="en-US" dirty="0"/>
+              <a:t>0˚</a:t>
+            </a:r>
+          </a:p>
+        </p:txBody>
+      </p:sp>
+      <p:sp>
+        <p:nvSpPr>
+          <p:cNvPr id="15" name="TextBox 14">
+            <a:extLst>
+              <a:ext uri="{FF2B5EF4-FFF2-40B4-BE49-F238E27FC236}">
+                <a16:creationId xmlns:a16="http://schemas.microsoft.com/office/drawing/2014/main" id="{E82253CC-B288-7931-82E2-64E4477065F8}"/>
+              </a:ext>
+            </a:extLst>
+          </p:cNvPr>
+          <p:cNvSpPr txBox="1"/>
+          <p:nvPr/>
+        </p:nvSpPr>
+        <p:spPr>
+          <a:xfrm>
+            <a:off x="9504684" y="3608661"/>
+            <a:ext cx="904274" cy="369332"/>
+          </a:xfrm>
+          <a:prstGeom prst="rect">
+            <a:avLst/>
+          </a:prstGeom>
+          <a:noFill/>
+        </p:spPr>
+        <p:txBody>
+          <a:bodyPr wrap="square" rtlCol="0">
+            <a:spAutoFit/>
+          </a:bodyPr>
+          <a:lstStyle/>
+          <a:p>
+            <a:r>
+              <a:rPr lang="en-US" dirty="0"/>
+              <a:t>180˚</a:t>
+            </a:r>
+          </a:p>
+        </p:txBody>
+      </p:sp>
+      <p:sp>
+        <p:nvSpPr>
+          <p:cNvPr id="16" name="Arrow: Right 15">
+            <a:extLst>
+              <a:ext uri="{FF2B5EF4-FFF2-40B4-BE49-F238E27FC236}">
+                <a16:creationId xmlns:a16="http://schemas.microsoft.com/office/drawing/2014/main" id="{E1D3A37A-2385-C819-B3EA-7C8697CB60A2}"/>
+              </a:ext>
+            </a:extLst>
+          </p:cNvPr>
+          <p:cNvSpPr/>
+          <p:nvPr/>
+        </p:nvSpPr>
+        <p:spPr>
+          <a:xfrm>
+            <a:off x="4212426" y="713320"/>
+            <a:ext cx="655665" cy="278212"/>
+          </a:xfrm>
+          <a:prstGeom prst="rightArrow">
+            <a:avLst/>
+          </a:prstGeom>
+        </p:spPr>
+        <p:style>
+          <a:lnRef idx="2">
+            <a:schemeClr val="accent1">
+              <a:shade val="15000"/>
+            </a:schemeClr>
+          </a:lnRef>
+          <a:fillRef idx="1">
+            <a:schemeClr val="accent1"/>
+          </a:fillRef>
+          <a:effectRef idx="0">
+            <a:schemeClr val="accent1"/>
+          </a:effectRef>
+          <a:fontRef idx="minor">
+            <a:schemeClr val="lt1"/>
+          </a:fontRef>
+        </p:style>
+        <p:txBody>
+          <a:bodyPr rtlCol="0" anchor="ctr"/>
+          <a:lstStyle/>
+          <a:p>
+            <a:pPr algn="ctr"/>
+            <a:endParaRPr lang="en-US"/>
+          </a:p>
+        </p:txBody>
+      </p:sp>
+      <p:grpSp>
+        <p:nvGrpSpPr>
+          <p:cNvPr id="23" name="Group 22">
+            <a:extLst>
+              <a:ext uri="{FF2B5EF4-FFF2-40B4-BE49-F238E27FC236}">
+                <a16:creationId xmlns:a16="http://schemas.microsoft.com/office/drawing/2014/main" id="{5CEAF00A-8FB2-F5D5-5CFC-FE6233F4D63C}"/>
+              </a:ext>
+            </a:extLst>
+          </p:cNvPr>
+          <p:cNvGrpSpPr/>
+          <p:nvPr/>
+        </p:nvGrpSpPr>
+        <p:grpSpPr>
+          <a:xfrm>
+            <a:off x="4868091" y="164675"/>
+            <a:ext cx="1919150" cy="1375501"/>
+            <a:chOff x="4919018" y="482173"/>
+            <a:chExt cx="1919150" cy="1375501"/>
+          </a:xfrm>
+        </p:grpSpPr>
+        <p:sp>
+          <p:nvSpPr>
+            <p:cNvPr id="18" name="Rectangle: Rounded Corners 17">
+              <a:extLst>
+                <a:ext uri="{FF2B5EF4-FFF2-40B4-BE49-F238E27FC236}">
+                  <a16:creationId xmlns:a16="http://schemas.microsoft.com/office/drawing/2014/main" id="{84EAF918-24E5-65F1-4CCF-80F5FDADD5D0}"/>
+                </a:ext>
+              </a:extLst>
+            </p:cNvPr>
+            <p:cNvSpPr/>
+            <p:nvPr/>
+          </p:nvSpPr>
+          <p:spPr>
+            <a:xfrm>
+              <a:off x="4939042" y="482173"/>
+              <a:ext cx="1836227" cy="1375501"/>
+            </a:xfrm>
+            <a:prstGeom prst="roundRect">
+              <a:avLst/>
+            </a:prstGeom>
+          </p:spPr>
+          <p:style>
+            <a:lnRef idx="2">
+              <a:schemeClr val="accent1">
+                <a:shade val="15000"/>
+              </a:schemeClr>
+            </a:lnRef>
+            <a:fillRef idx="1">
+              <a:schemeClr val="accent1"/>
+            </a:fillRef>
+            <a:effectRef idx="0">
+              <a:schemeClr val="accent1"/>
+            </a:effectRef>
+            <a:fontRef idx="minor">
+              <a:schemeClr val="lt1"/>
+            </a:fontRef>
+          </p:style>
+          <p:txBody>
+            <a:bodyPr rtlCol="0" anchor="ctr"/>
+            <a:lstStyle/>
+            <a:p>
+              <a:pPr algn="ctr"/>
+              <a:endParaRPr lang="en-US"/>
+            </a:p>
+          </p:txBody>
+        </p:sp>
+        <p:sp>
+          <p:nvSpPr>
+            <p:cNvPr id="19" name="TextBox 18">
+              <a:extLst>
+                <a:ext uri="{FF2B5EF4-FFF2-40B4-BE49-F238E27FC236}">
+                  <a16:creationId xmlns:a16="http://schemas.microsoft.com/office/drawing/2014/main" id="{4B2A546F-0783-740B-E3B1-602FEB58E9F3}"/>
+                </a:ext>
+              </a:extLst>
+            </p:cNvPr>
+            <p:cNvSpPr txBox="1"/>
+            <p:nvPr/>
+          </p:nvSpPr>
+          <p:spPr>
+            <a:xfrm>
+              <a:off x="5055966" y="482173"/>
+              <a:ext cx="1151696" cy="369332"/>
+            </a:xfrm>
+            <a:prstGeom prst="rect">
+              <a:avLst/>
+            </a:prstGeom>
+            <a:noFill/>
+          </p:spPr>
+          <p:txBody>
+            <a:bodyPr wrap="square" rtlCol="0">
+              <a:spAutoFit/>
+            </a:bodyPr>
+            <a:lstStyle/>
+            <a:p>
+              <a:r>
+                <a:rPr lang="en-US" dirty="0"/>
+                <a:t>BAL0212</a:t>
+              </a:r>
+            </a:p>
+          </p:txBody>
+        </p:sp>
+        <p:sp>
+          <p:nvSpPr>
+            <p:cNvPr id="20" name="TextBox 19">
+              <a:extLst>
+                <a:ext uri="{FF2B5EF4-FFF2-40B4-BE49-F238E27FC236}">
+                  <a16:creationId xmlns:a16="http://schemas.microsoft.com/office/drawing/2014/main" id="{A15DC666-00E9-53DC-1EF8-CEF2CBB3B0F8}"/>
+                </a:ext>
+              </a:extLst>
+            </p:cNvPr>
+            <p:cNvSpPr txBox="1"/>
+            <p:nvPr/>
+          </p:nvSpPr>
+          <p:spPr>
+            <a:xfrm>
+              <a:off x="4919018" y="921091"/>
+              <a:ext cx="566058" cy="369332"/>
+            </a:xfrm>
+            <a:prstGeom prst="rect">
+              <a:avLst/>
+            </a:prstGeom>
+            <a:noFill/>
+          </p:spPr>
+          <p:txBody>
+            <a:bodyPr wrap="square" rtlCol="0">
+              <a:spAutoFit/>
+            </a:bodyPr>
+            <a:lstStyle/>
+            <a:p>
+              <a:r>
+                <a:rPr lang="en-US" dirty="0"/>
+                <a:t>IN</a:t>
+              </a:r>
+            </a:p>
+          </p:txBody>
+        </p:sp>
+        <p:sp>
+          <p:nvSpPr>
+            <p:cNvPr id="21" name="TextBox 20">
+              <a:extLst>
+                <a:ext uri="{FF2B5EF4-FFF2-40B4-BE49-F238E27FC236}">
+                  <a16:creationId xmlns:a16="http://schemas.microsoft.com/office/drawing/2014/main" id="{7FE648DC-E416-3845-FA2C-E7894D55D9E1}"/>
+                </a:ext>
+              </a:extLst>
+            </p:cNvPr>
+            <p:cNvSpPr txBox="1"/>
+            <p:nvPr/>
+          </p:nvSpPr>
+          <p:spPr>
+            <a:xfrm>
+              <a:off x="4977851" y="1461918"/>
+              <a:ext cx="961608" cy="369332"/>
+            </a:xfrm>
+            <a:prstGeom prst="rect">
+              <a:avLst/>
+            </a:prstGeom>
+            <a:noFill/>
+          </p:spPr>
+          <p:txBody>
+            <a:bodyPr wrap="square" rtlCol="0">
+              <a:spAutoFit/>
+            </a:bodyPr>
+            <a:lstStyle/>
+            <a:p>
+              <a:r>
+                <a:rPr lang="en-US" dirty="0"/>
+                <a:t>OUT1</a:t>
+              </a:r>
+            </a:p>
+          </p:txBody>
+        </p:sp>
+        <p:sp>
+          <p:nvSpPr>
+            <p:cNvPr id="22" name="TextBox 21">
+              <a:extLst>
+                <a:ext uri="{FF2B5EF4-FFF2-40B4-BE49-F238E27FC236}">
+                  <a16:creationId xmlns:a16="http://schemas.microsoft.com/office/drawing/2014/main" id="{C219F4EB-2547-B3F4-1F93-F080471B3640}"/>
+                </a:ext>
+              </a:extLst>
+            </p:cNvPr>
+            <p:cNvSpPr txBox="1"/>
+            <p:nvPr/>
+          </p:nvSpPr>
+          <p:spPr>
+            <a:xfrm>
+              <a:off x="5876560" y="1456040"/>
+              <a:ext cx="961608" cy="369332"/>
+            </a:xfrm>
+            <a:prstGeom prst="rect">
+              <a:avLst/>
+            </a:prstGeom>
+            <a:noFill/>
+          </p:spPr>
+          <p:txBody>
+            <a:bodyPr wrap="square" rtlCol="0">
+              <a:spAutoFit/>
+            </a:bodyPr>
+            <a:lstStyle/>
+            <a:p>
+              <a:r>
+                <a:rPr lang="en-US" dirty="0"/>
+                <a:t>OUT2</a:t>
+              </a:r>
+            </a:p>
+          </p:txBody>
+        </p:sp>
+      </p:grpSp>
+      <p:sp>
+        <p:nvSpPr>
+          <p:cNvPr id="24" name="Arrow: Right 23">
+            <a:extLst>
+              <a:ext uri="{FF2B5EF4-FFF2-40B4-BE49-F238E27FC236}">
+                <a16:creationId xmlns:a16="http://schemas.microsoft.com/office/drawing/2014/main" id="{28FD5C87-1939-8F7F-9D2D-3B750DA9423A}"/>
+              </a:ext>
+            </a:extLst>
+          </p:cNvPr>
+          <p:cNvSpPr/>
+          <p:nvPr/>
+        </p:nvSpPr>
+        <p:spPr>
+          <a:xfrm rot="5400000">
+            <a:off x="5033554" y="1514259"/>
+            <a:ext cx="235131" cy="369332"/>
+          </a:xfrm>
+          <a:prstGeom prst="rightArrow">
+            <a:avLst/>
+          </a:prstGeom>
+        </p:spPr>
+        <p:style>
+          <a:lnRef idx="2">
+            <a:schemeClr val="accent1">
+              <a:shade val="15000"/>
+            </a:schemeClr>
+          </a:lnRef>
+          <a:fillRef idx="1">
+            <a:schemeClr val="accent1"/>
+          </a:fillRef>
+          <a:effectRef idx="0">
+            <a:schemeClr val="accent1"/>
+          </a:effectRef>
+          <a:fontRef idx="minor">
+            <a:schemeClr val="lt1"/>
+          </a:fontRef>
+        </p:style>
+        <p:txBody>
+          <a:bodyPr rtlCol="0" anchor="ctr"/>
+          <a:lstStyle/>
+          <a:p>
+            <a:pPr algn="ctr"/>
+            <a:endParaRPr lang="en-US"/>
+          </a:p>
+        </p:txBody>
+      </p:sp>
+      <p:sp>
+        <p:nvSpPr>
+          <p:cNvPr id="25" name="Arrow: Right 24">
+            <a:extLst>
+              <a:ext uri="{FF2B5EF4-FFF2-40B4-BE49-F238E27FC236}">
+                <a16:creationId xmlns:a16="http://schemas.microsoft.com/office/drawing/2014/main" id="{7CF0CA90-4C3C-76C8-CB18-59AEE65CAEB9}"/>
+              </a:ext>
+            </a:extLst>
+          </p:cNvPr>
+          <p:cNvSpPr/>
+          <p:nvPr/>
+        </p:nvSpPr>
+        <p:spPr>
+          <a:xfrm rot="5400000">
+            <a:off x="5793767" y="1527005"/>
+            <a:ext cx="235131" cy="369332"/>
+          </a:xfrm>
+          <a:prstGeom prst="rightArrow">
+            <a:avLst/>
+          </a:prstGeom>
+        </p:spPr>
+        <p:style>
+          <a:lnRef idx="2">
+            <a:schemeClr val="accent1">
+              <a:shade val="15000"/>
+            </a:schemeClr>
+          </a:lnRef>
+          <a:fillRef idx="1">
+            <a:schemeClr val="accent1"/>
+          </a:fillRef>
+          <a:effectRef idx="0">
+            <a:schemeClr val="accent1"/>
+          </a:effectRef>
+          <a:fontRef idx="minor">
+            <a:schemeClr val="lt1"/>
+          </a:fontRef>
+        </p:style>
+        <p:txBody>
+          <a:bodyPr rtlCol="0" anchor="ctr"/>
+          <a:lstStyle/>
+          <a:p>
+            <a:pPr algn="ctr"/>
+            <a:endParaRPr lang="en-US"/>
+          </a:p>
+        </p:txBody>
+      </p:sp>
+      <p:grpSp>
+        <p:nvGrpSpPr>
+          <p:cNvPr id="26" name="Group 25">
+            <a:extLst>
+              <a:ext uri="{FF2B5EF4-FFF2-40B4-BE49-F238E27FC236}">
+                <a16:creationId xmlns:a16="http://schemas.microsoft.com/office/drawing/2014/main" id="{0E93E3F6-D77D-CBEB-58B9-A5F6CED5F207}"/>
+              </a:ext>
+            </a:extLst>
+          </p:cNvPr>
+          <p:cNvGrpSpPr/>
+          <p:nvPr/>
+        </p:nvGrpSpPr>
+        <p:grpSpPr>
+          <a:xfrm>
+            <a:off x="1939161" y="2920910"/>
+            <a:ext cx="2064718" cy="1375501"/>
+            <a:chOff x="4919018" y="482173"/>
+            <a:chExt cx="2064718" cy="1375501"/>
+          </a:xfrm>
+        </p:grpSpPr>
+        <p:sp>
+          <p:nvSpPr>
+            <p:cNvPr id="27" name="Rectangle: Rounded Corners 26">
+              <a:extLst>
+                <a:ext uri="{FF2B5EF4-FFF2-40B4-BE49-F238E27FC236}">
+                  <a16:creationId xmlns:a16="http://schemas.microsoft.com/office/drawing/2014/main" id="{D9C5BB9D-ED0A-40EA-0602-821B632CD998}"/>
+                </a:ext>
+              </a:extLst>
+            </p:cNvPr>
+            <p:cNvSpPr/>
+            <p:nvPr/>
+          </p:nvSpPr>
+          <p:spPr>
+            <a:xfrm>
+              <a:off x="4939042" y="482173"/>
+              <a:ext cx="1836227" cy="1375501"/>
+            </a:xfrm>
+            <a:prstGeom prst="roundRect">
+              <a:avLst/>
+            </a:prstGeom>
+          </p:spPr>
+          <p:style>
+            <a:lnRef idx="2">
+              <a:schemeClr val="accent1">
+                <a:shade val="15000"/>
+              </a:schemeClr>
+            </a:lnRef>
+            <a:fillRef idx="1">
+              <a:schemeClr val="accent1"/>
+            </a:fillRef>
+            <a:effectRef idx="0">
+              <a:schemeClr val="accent1"/>
+            </a:effectRef>
+            <a:fontRef idx="minor">
+              <a:schemeClr val="lt1"/>
+            </a:fontRef>
+          </p:style>
+          <p:txBody>
+            <a:bodyPr rtlCol="0" anchor="ctr"/>
+            <a:lstStyle/>
+            <a:p>
+              <a:pPr algn="ctr"/>
+              <a:endParaRPr lang="en-US"/>
+            </a:p>
+          </p:txBody>
+        </p:sp>
+        <p:sp>
+          <p:nvSpPr>
+            <p:cNvPr id="28" name="TextBox 27">
+              <a:extLst>
+                <a:ext uri="{FF2B5EF4-FFF2-40B4-BE49-F238E27FC236}">
+                  <a16:creationId xmlns:a16="http://schemas.microsoft.com/office/drawing/2014/main" id="{0417E55F-4C0B-3E0C-235C-73B82D153C97}"/>
+                </a:ext>
+              </a:extLst>
+            </p:cNvPr>
+            <p:cNvSpPr txBox="1"/>
+            <p:nvPr/>
+          </p:nvSpPr>
+          <p:spPr>
+            <a:xfrm>
+              <a:off x="5055966" y="482173"/>
+              <a:ext cx="1151696" cy="369332"/>
+            </a:xfrm>
+            <a:prstGeom prst="rect">
+              <a:avLst/>
+            </a:prstGeom>
+            <a:noFill/>
+          </p:spPr>
+          <p:txBody>
+            <a:bodyPr wrap="square" rtlCol="0">
+              <a:spAutoFit/>
+            </a:bodyPr>
+            <a:lstStyle/>
+            <a:p>
+              <a:r>
+                <a:rPr lang="en-US" dirty="0"/>
+                <a:t>BAL0520</a:t>
+              </a:r>
+            </a:p>
+          </p:txBody>
+        </p:sp>
+        <p:sp>
+          <p:nvSpPr>
+            <p:cNvPr id="29" name="TextBox 28">
+              <a:extLst>
+                <a:ext uri="{FF2B5EF4-FFF2-40B4-BE49-F238E27FC236}">
+                  <a16:creationId xmlns:a16="http://schemas.microsoft.com/office/drawing/2014/main" id="{D6A6B222-E483-58F3-84A6-5F78A0C4666D}"/>
+                </a:ext>
+              </a:extLst>
+            </p:cNvPr>
+            <p:cNvSpPr txBox="1"/>
+            <p:nvPr/>
+          </p:nvSpPr>
+          <p:spPr>
+            <a:xfrm>
+              <a:off x="4919018" y="921091"/>
+              <a:ext cx="566058" cy="369332"/>
+            </a:xfrm>
+            <a:prstGeom prst="rect">
+              <a:avLst/>
+            </a:prstGeom>
+            <a:noFill/>
+          </p:spPr>
+          <p:txBody>
+            <a:bodyPr wrap="square" rtlCol="0">
+              <a:spAutoFit/>
+            </a:bodyPr>
+            <a:lstStyle/>
+            <a:p>
+              <a:r>
+                <a:rPr lang="en-US" dirty="0"/>
+                <a:t>IN</a:t>
+              </a:r>
+            </a:p>
+          </p:txBody>
+        </p:sp>
+        <p:sp>
+          <p:nvSpPr>
+            <p:cNvPr id="30" name="TextBox 29">
+              <a:extLst>
+                <a:ext uri="{FF2B5EF4-FFF2-40B4-BE49-F238E27FC236}">
+                  <a16:creationId xmlns:a16="http://schemas.microsoft.com/office/drawing/2014/main" id="{9453FD72-5FF2-C46A-DBEF-98BCD81D1286}"/>
+                </a:ext>
+              </a:extLst>
+            </p:cNvPr>
+            <p:cNvSpPr txBox="1"/>
+            <p:nvPr/>
+          </p:nvSpPr>
+          <p:spPr>
+            <a:xfrm>
+              <a:off x="6022128" y="701632"/>
+              <a:ext cx="961608" cy="369332"/>
+            </a:xfrm>
+            <a:prstGeom prst="rect">
+              <a:avLst/>
+            </a:prstGeom>
+            <a:noFill/>
+          </p:spPr>
+          <p:txBody>
+            <a:bodyPr wrap="square" rtlCol="0">
+              <a:spAutoFit/>
+            </a:bodyPr>
+            <a:lstStyle/>
+            <a:p>
+              <a:r>
+                <a:rPr lang="en-US" dirty="0"/>
+                <a:t>OUT1</a:t>
+              </a:r>
+            </a:p>
+          </p:txBody>
+        </p:sp>
+        <p:sp>
+          <p:nvSpPr>
+            <p:cNvPr id="31" name="TextBox 30">
+              <a:extLst>
+                <a:ext uri="{FF2B5EF4-FFF2-40B4-BE49-F238E27FC236}">
+                  <a16:creationId xmlns:a16="http://schemas.microsoft.com/office/drawing/2014/main" id="{83F2E951-24E1-5AEA-0E74-95A04565D88D}"/>
+                </a:ext>
+              </a:extLst>
+            </p:cNvPr>
+            <p:cNvSpPr txBox="1"/>
+            <p:nvPr/>
+          </p:nvSpPr>
+          <p:spPr>
+            <a:xfrm>
+              <a:off x="5991056" y="1279653"/>
+              <a:ext cx="961608" cy="369332"/>
+            </a:xfrm>
+            <a:prstGeom prst="rect">
+              <a:avLst/>
+            </a:prstGeom>
+            <a:noFill/>
+          </p:spPr>
+          <p:txBody>
+            <a:bodyPr wrap="square" rtlCol="0">
+              <a:spAutoFit/>
+            </a:bodyPr>
+            <a:lstStyle/>
+            <a:p>
+              <a:r>
+                <a:rPr lang="en-US" dirty="0"/>
+                <a:t>OUT2</a:t>
+              </a:r>
+            </a:p>
+          </p:txBody>
+        </p:sp>
+      </p:grpSp>
+      <p:pic>
+        <p:nvPicPr>
+          <p:cNvPr id="32" name="Picture 4" descr="N9960A FieldFox Handheld Microwave Spectrum Analyzer, 32 GHz">
+            <a:extLst>
+              <a:ext uri="{FF2B5EF4-FFF2-40B4-BE49-F238E27FC236}">
+                <a16:creationId xmlns:a16="http://schemas.microsoft.com/office/drawing/2014/main" id="{AB7481FA-DD14-0C12-B8D8-7A2A7B27120D}"/>
+              </a:ext>
+            </a:extLst>
+          </p:cNvPr>
+          <p:cNvPicPr>
+            <a:picLocks noChangeAspect="1" noChangeArrowheads="1"/>
+          </p:cNvPicPr>
+          <p:nvPr/>
+        </p:nvPicPr>
+        <p:blipFill rotWithShape="1">
+          <a:blip r:embed="rId4">
+            <a:extLst>
+              <a:ext uri="{28A0092B-C50C-407E-A947-70E740481C1C}">
+                <a14:useLocalDpi xmlns:a14="http://schemas.microsoft.com/office/drawing/2010/main" val="0"/>
+              </a:ext>
+            </a:extLst>
+          </a:blip>
+          <a:srcRect l="29239" t="6860" r="32989" b="5507"/>
+          <a:stretch/>
+        </p:blipFill>
+        <p:spPr bwMode="auto">
+          <a:xfrm flipH="1">
+            <a:off x="91067" y="2678094"/>
+            <a:ext cx="1594279" cy="2080592"/>
+          </a:xfrm>
+          <a:prstGeom prst="rect">
+            <a:avLst/>
+          </a:prstGeom>
+          <a:noFill/>
+          <a:extLst>
+            <a:ext uri="{909E8E84-426E-40DD-AFC4-6F175D3DCCD1}">
+              <a14:hiddenFill xmlns:a14="http://schemas.microsoft.com/office/drawing/2010/main">
+                <a:solidFill>
+                  <a:srgbClr val="FFFFFF"/>
+                </a:solidFill>
+              </a14:hiddenFill>
+            </a:ext>
+          </a:extLst>
+        </p:spPr>
+      </p:pic>
+      <p:sp>
+        <p:nvSpPr>
+          <p:cNvPr id="33" name="Arrow: Right 32">
+            <a:extLst>
+              <a:ext uri="{FF2B5EF4-FFF2-40B4-BE49-F238E27FC236}">
+                <a16:creationId xmlns:a16="http://schemas.microsoft.com/office/drawing/2014/main" id="{D4F796A9-A727-C44D-31B3-F002F3F9D4A2}"/>
+              </a:ext>
+            </a:extLst>
+          </p:cNvPr>
+          <p:cNvSpPr/>
+          <p:nvPr/>
+        </p:nvSpPr>
+        <p:spPr>
+          <a:xfrm rot="10800000">
+            <a:off x="3831957" y="3174774"/>
+            <a:ext cx="235131" cy="369332"/>
+          </a:xfrm>
+          <a:prstGeom prst="rightArrow">
+            <a:avLst/>
+          </a:prstGeom>
+        </p:spPr>
+        <p:style>
+          <a:lnRef idx="2">
+            <a:schemeClr val="accent1">
+              <a:shade val="15000"/>
+            </a:schemeClr>
+          </a:lnRef>
+          <a:fillRef idx="1">
+            <a:schemeClr val="accent1"/>
+          </a:fillRef>
+          <a:effectRef idx="0">
+            <a:schemeClr val="accent1"/>
+          </a:effectRef>
+          <a:fontRef idx="minor">
+            <a:schemeClr val="lt1"/>
+          </a:fontRef>
+        </p:style>
+        <p:txBody>
+          <a:bodyPr rtlCol="0" anchor="ctr"/>
+          <a:lstStyle/>
+          <a:p>
+            <a:pPr algn="ctr"/>
+            <a:endParaRPr lang="en-US"/>
+          </a:p>
+        </p:txBody>
+      </p:sp>
+      <p:sp>
+        <p:nvSpPr>
+          <p:cNvPr id="34" name="Arrow: Right 33">
+            <a:extLst>
+              <a:ext uri="{FF2B5EF4-FFF2-40B4-BE49-F238E27FC236}">
+                <a16:creationId xmlns:a16="http://schemas.microsoft.com/office/drawing/2014/main" id="{F70005A2-716A-63AA-B4F4-72145405162D}"/>
+              </a:ext>
+            </a:extLst>
+          </p:cNvPr>
+          <p:cNvSpPr/>
+          <p:nvPr/>
+        </p:nvSpPr>
+        <p:spPr>
+          <a:xfrm rot="10800000">
+            <a:off x="3828431" y="3728772"/>
+            <a:ext cx="235131" cy="369332"/>
+          </a:xfrm>
+          <a:prstGeom prst="rightArrow">
+            <a:avLst/>
+          </a:prstGeom>
+        </p:spPr>
+        <p:style>
+          <a:lnRef idx="2">
+            <a:schemeClr val="accent1">
+              <a:shade val="15000"/>
+            </a:schemeClr>
+          </a:lnRef>
+          <a:fillRef idx="1">
+            <a:schemeClr val="accent1"/>
+          </a:fillRef>
+          <a:effectRef idx="0">
+            <a:schemeClr val="accent1"/>
+          </a:effectRef>
+          <a:fontRef idx="minor">
+            <a:schemeClr val="lt1"/>
+          </a:fontRef>
+        </p:style>
+        <p:txBody>
+          <a:bodyPr rtlCol="0" anchor="ctr"/>
+          <a:lstStyle/>
+          <a:p>
+            <a:pPr algn="ctr"/>
+            <a:endParaRPr lang="en-US"/>
+          </a:p>
+        </p:txBody>
+      </p:sp>
+      <p:sp>
+        <p:nvSpPr>
+          <p:cNvPr id="35" name="Arrow: Right 34">
+            <a:extLst>
+              <a:ext uri="{FF2B5EF4-FFF2-40B4-BE49-F238E27FC236}">
+                <a16:creationId xmlns:a16="http://schemas.microsoft.com/office/drawing/2014/main" id="{342992D9-29B5-BA00-F378-BE61FAA4F534}"/>
+              </a:ext>
+            </a:extLst>
+          </p:cNvPr>
+          <p:cNvSpPr/>
+          <p:nvPr/>
+        </p:nvSpPr>
+        <p:spPr>
+          <a:xfrm rot="10800000">
+            <a:off x="1625126" y="3404673"/>
+            <a:ext cx="235131" cy="369332"/>
+          </a:xfrm>
+          <a:prstGeom prst="rightArrow">
+            <a:avLst/>
+          </a:prstGeom>
+        </p:spPr>
+        <p:style>
+          <a:lnRef idx="2">
+            <a:schemeClr val="accent1">
+              <a:shade val="15000"/>
+            </a:schemeClr>
+          </a:lnRef>
+          <a:fillRef idx="1">
+            <a:schemeClr val="accent1"/>
+          </a:fillRef>
+          <a:effectRef idx="0">
+            <a:schemeClr val="accent1"/>
+          </a:effectRef>
+          <a:fontRef idx="minor">
+            <a:schemeClr val="lt1"/>
+          </a:fontRef>
+        </p:style>
+        <p:txBody>
+          <a:bodyPr rtlCol="0" anchor="ctr"/>
+          <a:lstStyle/>
+          <a:p>
+            <a:pPr algn="ctr"/>
+            <a:endParaRPr lang="en-US"/>
+          </a:p>
+        </p:txBody>
+      </p:sp>
+      <p:sp>
+        <p:nvSpPr>
+          <p:cNvPr id="36" name="Arrow: Bent 35">
+            <a:extLst>
+              <a:ext uri="{FF2B5EF4-FFF2-40B4-BE49-F238E27FC236}">
+                <a16:creationId xmlns:a16="http://schemas.microsoft.com/office/drawing/2014/main" id="{5E07859D-5B95-4DD7-ABB1-794AD305DA04}"/>
+              </a:ext>
+            </a:extLst>
+          </p:cNvPr>
+          <p:cNvSpPr/>
+          <p:nvPr/>
+        </p:nvSpPr>
+        <p:spPr>
+          <a:xfrm>
+            <a:off x="6958458" y="1412846"/>
+            <a:ext cx="870441" cy="799974"/>
+          </a:xfrm>
+          <a:prstGeom prst="bentArrow">
+            <a:avLst/>
+          </a:prstGeom>
+        </p:spPr>
+        <p:style>
+          <a:lnRef idx="2">
+            <a:schemeClr val="accent1">
+              <a:shade val="15000"/>
+            </a:schemeClr>
+          </a:lnRef>
+          <a:fillRef idx="1">
+            <a:schemeClr val="accent1"/>
+          </a:fillRef>
+          <a:effectRef idx="0">
+            <a:schemeClr val="accent1"/>
+          </a:effectRef>
+          <a:fontRef idx="minor">
+            <a:schemeClr val="lt1"/>
+          </a:fontRef>
+        </p:style>
+        <p:txBody>
+          <a:bodyPr rtlCol="0" anchor="ctr"/>
+          <a:lstStyle/>
+          <a:p>
+            <a:pPr algn="ctr"/>
+            <a:endParaRPr lang="en-US">
+              <a:solidFill>
+                <a:schemeClr val="tx1"/>
+              </a:solidFill>
+            </a:endParaRPr>
+          </a:p>
+        </p:txBody>
+      </p:sp>
+      <p:sp>
+        <p:nvSpPr>
+          <p:cNvPr id="37" name="TextBox 36">
+            <a:extLst>
+              <a:ext uri="{FF2B5EF4-FFF2-40B4-BE49-F238E27FC236}">
+                <a16:creationId xmlns:a16="http://schemas.microsoft.com/office/drawing/2014/main" id="{43C06F22-62BB-F9E2-DBA8-11385913FAC8}"/>
+              </a:ext>
+            </a:extLst>
+          </p:cNvPr>
+          <p:cNvSpPr txBox="1"/>
+          <p:nvPr/>
+        </p:nvSpPr>
+        <p:spPr>
+          <a:xfrm>
+            <a:off x="7811172" y="1412846"/>
+            <a:ext cx="1244414" cy="369332"/>
+          </a:xfrm>
+          <a:prstGeom prst="rect">
+            <a:avLst/>
+          </a:prstGeom>
+          <a:noFill/>
+        </p:spPr>
+        <p:txBody>
+          <a:bodyPr wrap="square" rtlCol="0">
+            <a:spAutoFit/>
+          </a:bodyPr>
+          <a:lstStyle/>
+          <a:p>
+            <a:r>
+              <a:rPr lang="en-US" dirty="0"/>
+              <a:t>USB To PC</a:t>
+            </a:r>
+          </a:p>
+        </p:txBody>
+      </p:sp>
+    </p:spTree>
+    <p:extLst>
+      <p:ext uri="{BB962C8B-B14F-4D97-AF65-F5344CB8AC3E}">
+        <p14:creationId xmlns:p14="http://schemas.microsoft.com/office/powerpoint/2010/main" val="1895885319"/>
+      </p:ext>
+    </p:extLst>
+  </p:cSld>
+  <p:clrMapOvr>
+    <a:masterClrMapping/>
+  </p:clrMapOvr>
+</p:sld>
+</file>
+
 <file path=ppt/theme/theme1.xml><?xml version="1.0" encoding="utf-8"?>
 <a:theme xmlns:a="http://schemas.openxmlformats.org/drawingml/2006/main" name="Office Theme">
   <a:themeElements>

</xml_diff>